<commit_message>
Adaptar 3ESO a la programacion del departamento
</commit_message>
<xml_diff>
--- a/docs/recursos/PRESENTACION_INFORMATICA_3ESO_2026_2027.pptx
+++ b/docs/recursos/PRESENTACION_INFORMATICA_3ESO_2026_2027.pptx
@@ -2,22 +2,22 @@
 <file path=ppt/presentation.xml><?xml version="1.0" encoding="utf-8"?>
 <p:presentation xmlns:p="http://schemas.openxmlformats.org/presentationml/2006/main">
   <p:sldMasterIdLst>
-    <p:sldMasterId xmlns:r="http://schemas.openxmlformats.org/officeDocument/2006/relationships" id="2147483648" r:id="Rb68d6f5c56cf4b04"/>
+    <p:sldMasterId xmlns:r="http://schemas.openxmlformats.org/officeDocument/2006/relationships" id="2147483648" r:id="R56d077ce07d64e9d"/>
   </p:sldMasterIdLst>
   <p:notesMasterIdLst>
-    <p:notesMasterId xmlns:r="http://schemas.openxmlformats.org/officeDocument/2006/relationships" r:id="R0598c4697ed24b4b"/>
+    <p:notesMasterId xmlns:r="http://schemas.openxmlformats.org/officeDocument/2006/relationships" r:id="R9597376dcd6e4227"/>
   </p:notesMasterIdLst>
   <p:sldIdLst>
-    <p:sldId xmlns:r="http://schemas.openxmlformats.org/officeDocument/2006/relationships" id="256" r:id="R60326503327a4cc7"/>
-    <p:sldId xmlns:r="http://schemas.openxmlformats.org/officeDocument/2006/relationships" id="257" r:id="R0d54ff3186874492"/>
-    <p:sldId xmlns:r="http://schemas.openxmlformats.org/officeDocument/2006/relationships" id="258" r:id="R9ae2bba574824f96"/>
-    <p:sldId xmlns:r="http://schemas.openxmlformats.org/officeDocument/2006/relationships" id="259" r:id="R04f2ca617344449d"/>
-    <p:sldId xmlns:r="http://schemas.openxmlformats.org/officeDocument/2006/relationships" id="260" r:id="R089f73549afa4414"/>
-    <p:sldId xmlns:r="http://schemas.openxmlformats.org/officeDocument/2006/relationships" id="261" r:id="R0aab61ddbf06416e"/>
-    <p:sldId xmlns:r="http://schemas.openxmlformats.org/officeDocument/2006/relationships" id="262" r:id="Rbc31dff047ce421a"/>
-    <p:sldId xmlns:r="http://schemas.openxmlformats.org/officeDocument/2006/relationships" id="263" r:id="Ra8a9cd11e13a4688"/>
-    <p:sldId xmlns:r="http://schemas.openxmlformats.org/officeDocument/2006/relationships" id="264" r:id="R2eb62e09dea94f8a"/>
-    <p:sldId xmlns:r="http://schemas.openxmlformats.org/officeDocument/2006/relationships" id="265" r:id="Rdcc01233cbec4a23"/>
+    <p:sldId xmlns:r="http://schemas.openxmlformats.org/officeDocument/2006/relationships" id="256" r:id="R35df840e614a4a6a"/>
+    <p:sldId xmlns:r="http://schemas.openxmlformats.org/officeDocument/2006/relationships" id="257" r:id="Reb4f56fdd6fb4fa9"/>
+    <p:sldId xmlns:r="http://schemas.openxmlformats.org/officeDocument/2006/relationships" id="258" r:id="R74e4f868565144b9"/>
+    <p:sldId xmlns:r="http://schemas.openxmlformats.org/officeDocument/2006/relationships" id="259" r:id="Rc0b0c09083974147"/>
+    <p:sldId xmlns:r="http://schemas.openxmlformats.org/officeDocument/2006/relationships" id="260" r:id="Rd5d2d4f803604f8a"/>
+    <p:sldId xmlns:r="http://schemas.openxmlformats.org/officeDocument/2006/relationships" id="261" r:id="Rf676784d3f7345fe"/>
+    <p:sldId xmlns:r="http://schemas.openxmlformats.org/officeDocument/2006/relationships" id="262" r:id="Rfb4c6fff5ed9412e"/>
+    <p:sldId xmlns:r="http://schemas.openxmlformats.org/officeDocument/2006/relationships" id="263" r:id="Rc84f968495ab4580"/>
+    <p:sldId xmlns:r="http://schemas.openxmlformats.org/officeDocument/2006/relationships" id="264" r:id="R679f163088b544d7"/>
+    <p:sldId xmlns:r="http://schemas.openxmlformats.org/officeDocument/2006/relationships" id="265" r:id="R9522f3cf0e4045b2"/>
   </p:sldIdLst>
   <p:sldSz cx="12192000" cy="6858000"/>
   <p:notesSz cx="6858000" cy="9144000"/>
@@ -1279,7 +1279,7 @@
   </p:cSld>
   <p:clrMap bg1="lt1" tx1="dk1" bg2="lt2" tx2="dk2" accent1="accent1" accent2="accent2" accent3="accent3" accent4="accent4" accent5="accent5" accent6="accent6" hlink="hlink" folHlink="folHlink"/>
   <p:sldLayoutIdLst>
-    <p:sldLayoutId xmlns:r="http://schemas.openxmlformats.org/officeDocument/2006/relationships" id="2147483649" r:id="Rfef8b43e916e4b48"/>
+    <p:sldLayoutId xmlns:r="http://schemas.openxmlformats.org/officeDocument/2006/relationships" id="2147483649" r:id="Re722e670953d4b81"/>
   </p:sldLayoutIdLst>
   <p:txStyles>
     <p:titleStyle>
@@ -1834,7 +1834,7 @@
           <p:nvPr/>
         </p:nvPicPr>
         <p:blipFill>
-          <a:blip xmlns:r="http://schemas.openxmlformats.org/officeDocument/2006/relationships" xmlns:a="http://schemas.openxmlformats.org/drawingml/2006/main" r:embed="R2352d71a9a504a46"/>
+          <a:blip xmlns:r="http://schemas.openxmlformats.org/officeDocument/2006/relationships" xmlns:a="http://schemas.openxmlformats.org/drawingml/2006/main" r:embed="R549664e1c3584869"/>
           <a:srcRect xmlns:a="http://schemas.openxmlformats.org/drawingml/2006/main" l="0" t="27" r="0" b="27"/>
           <a:stretch xmlns:a="http://schemas.openxmlformats.org/drawingml/2006/main">
             <a:fillRect l="0" t="0" r="0" b="0"/>
@@ -4652,7 +4652,7 @@
                   <a:srgbClr val="22C7E8"/>
                 </a:solidFill>
               </a:rPr>
-              <a:t>1</a:t>
+              <a:t>6</a:t>
             </a:r>
           </a:p>
         </p:txBody>
@@ -4703,7 +4703,7 @@
                   <a:srgbClr val="FFFFFF"/>
                 </a:solidFill>
               </a:rPr>
-              <a:t>proyecto final de curso</a:t>
+              <a:t>proyectos de unidad</a:t>
             </a:r>
           </a:p>
         </p:txBody>
@@ -6339,7 +6339,7 @@
                   <a:srgbClr val="10263A"/>
                 </a:solidFill>
               </a:rPr>
-              <a:t>Entorno digital</a:t>
+              <a:t>Repaso y Excel</a:t>
             </a:r>
           </a:p>
         </p:txBody>
@@ -6558,7 +6558,7 @@
                   <a:srgbClr val="10263A"/>
                 </a:solidFill>
               </a:rPr>
-              <a:t>Ordenador y sistemas</a:t>
+              <a:t>Canva y diseño</a:t>
             </a:r>
           </a:p>
         </p:txBody>
@@ -6777,7 +6777,7 @@
                   <a:srgbClr val="10263A"/>
                 </a:solidFill>
               </a:rPr>
-              <a:t>Redes y seguridad</a:t>
+              <a:t>Scratch avanzado</a:t>
             </a:r>
           </a:p>
         </p:txBody>
@@ -6828,7 +6828,7 @@
                   <a:srgbClr val="587184"/>
                 </a:solidFill>
               </a:rPr>
-              <a:t>5 semanas</a:t>
+              <a:t>7 semanas</a:t>
             </a:r>
           </a:p>
         </p:txBody>
@@ -6996,7 +6996,7 @@
                   <a:srgbClr val="10263A"/>
                 </a:solidFill>
               </a:rPr>
-              <a:t>Documentos y datos</a:t>
+              <a:t>Micro:bit y robótica</a:t>
             </a:r>
           </a:p>
         </p:txBody>
@@ -7047,7 +7047,7 @@
                   <a:srgbClr val="587184"/>
                 </a:solidFill>
               </a:rPr>
-              <a:t>5 semanas</a:t>
+              <a:t>6 semanas</a:t>
             </a:r>
           </a:p>
         </p:txBody>
@@ -7215,7 +7215,7 @@
                   <a:srgbClr val="10263A"/>
                 </a:solidFill>
               </a:rPr>
-              <a:t>Creación multimedia</a:t>
+              <a:t>IA, agentes y automatización</a:t>
             </a:r>
           </a:p>
         </p:txBody>
@@ -7266,7 +7266,7 @@
                   <a:srgbClr val="587184"/>
                 </a:solidFill>
               </a:rPr>
-              <a:t>5 semanas</a:t>
+              <a:t>6 semanas</a:t>
             </a:r>
           </a:p>
         </p:txBody>
@@ -7434,7 +7434,7 @@
                   <a:srgbClr val="10263A"/>
                 </a:solidFill>
               </a:rPr>
-              <a:t>Programación y web</a:t>
+              <a:t>Introducción a Python</a:t>
             </a:r>
           </a:p>
         </p:txBody>
@@ -7602,7 +7602,7 @@
                   <a:srgbClr val="10263A"/>
                 </a:solidFill>
               </a:rPr>
-              <a:t>PF</a:t>
+              <a:t>T</a:t>
             </a:r>
           </a:p>
         </p:txBody>
@@ -7653,7 +7653,7 @@
                   <a:srgbClr val="10263A"/>
                 </a:solidFill>
               </a:rPr>
-              <a:t>Proyecto final</a:t>
+              <a:t>Trabajo transversal</a:t>
             </a:r>
           </a:p>
         </p:txBody>
@@ -7704,7 +7704,7 @@
                   <a:srgbClr val="587184"/>
                 </a:solidFill>
               </a:rPr>
-              <a:t>4 semanas</a:t>
+              <a:t>Todo el curso</a:t>
             </a:r>
           </a:p>
         </p:txBody>
@@ -9708,7 +9708,7 @@
           <p:nvPr/>
         </p:nvPicPr>
         <p:blipFill>
-          <a:blip xmlns:r="http://schemas.openxmlformats.org/officeDocument/2006/relationships" xmlns:a="http://schemas.openxmlformats.org/drawingml/2006/main" r:embed="R8b2ad7673b0d4172"/>
+          <a:blip xmlns:r="http://schemas.openxmlformats.org/officeDocument/2006/relationships" xmlns:a="http://schemas.openxmlformats.org/drawingml/2006/main" r:embed="R2c638df4caca4b64"/>
           <a:stretch xmlns:a="http://schemas.openxmlformats.org/drawingml/2006/main"/>
         </p:blipFill>
         <p:spPr>

</xml_diff>